<commit_message>
Brand IndulgeTix executive deck
</commit_message>
<xml_diff>
--- a/02-product-case-studies/indulgetix-ticketing-platform/Deck/Executive_Deck.pptx
+++ b/02-product-case-studies/indulgetix-ticketing-platform/Deck/Executive_Deck.pptx
@@ -1480,7 +1480,7 @@
     <p:bg>
       <p:bgPr>
         <a:solidFill>
-          <a:srgbClr val="15253D"/>
+          <a:srgbClr val="201F20"/>
         </a:solidFill>
       </p:bgPr>
     </p:bg>
@@ -1507,7 +1507,7 @@
         <p:spPr>
           <a:xfrm>
             <a:off x="731520" y="1188720"/>
-            <a:ext cx="7315200" cy="365760"/>
+            <a:ext cx="6217920" cy="365760"/>
           </a:xfrm>
           <a:prstGeom prst="rect">
             <a:avLst/>
@@ -1525,7 +1525,7 @@
             <a:r>
               <a:rPr lang="en-US" sz="1300" b="1" spc="200" kern="0" dirty="0">
                 <a:solidFill>
-                  <a:srgbClr val="5EEAD4"/>
+                  <a:srgbClr val="F0561A"/>
                 </a:solidFill>
                 <a:latin typeface="Arial" pitchFamily="34" charset="0"/>
                 <a:ea typeface="Arial" pitchFamily="34" charset="-122"/>
@@ -1546,7 +1546,7 @@
         <p:spPr>
           <a:xfrm>
             <a:off x="731520" y="1645920"/>
-            <a:ext cx="10515600" cy="1463040"/>
+            <a:ext cx="6217920" cy="1463040"/>
           </a:xfrm>
           <a:prstGeom prst="rect">
             <a:avLst/>
@@ -1562,7 +1562,7 @@
               <a:buNone/>
             </a:pPr>
             <a:r>
-              <a:rPr lang="en-US" sz="4000" b="1" dirty="0">
+              <a:rPr lang="en-US" sz="3400" b="1" dirty="0">
                 <a:solidFill>
                   <a:srgbClr val="FFFFFF"/>
                 </a:solidFill>
@@ -1585,7 +1585,7 @@
         <p:spPr>
           <a:xfrm>
             <a:off x="731520" y="3291840"/>
-            <a:ext cx="10058400" cy="822960"/>
+            <a:ext cx="6217920" cy="822960"/>
           </a:xfrm>
           <a:prstGeom prst="rect">
             <a:avLst/>
@@ -1624,7 +1624,7 @@
         <p:spPr>
           <a:xfrm>
             <a:off x="731520" y="4663440"/>
-            <a:ext cx="2743200" cy="0"/>
+            <a:ext cx="6217920" cy="0"/>
           </a:xfrm>
           <a:prstGeom prst="line">
             <a:avLst/>
@@ -1632,11 +1632,15 @@
           <a:noFill/>
           <a:ln w="25400">
             <a:solidFill>
-              <a:srgbClr val="5EEAD4"/>
+              <a:srgbClr val="F0561A"/>
             </a:solidFill>
             <a:prstDash val="solid"/>
           </a:ln>
         </p:spPr>
+        <p:txBody>
+          <a:bodyPr/>
+          <a:p/>
+        </p:txBody>
       </p:sp>
       <p:sp>
         <p:nvSpPr>
@@ -1647,7 +1651,7 @@
         <p:spPr>
           <a:xfrm>
             <a:off x="731520" y="4846320"/>
-            <a:ext cx="10058400" cy="1097280"/>
+            <a:ext cx="6217920" cy="1097280"/>
           </a:xfrm>
           <a:prstGeom prst="rect">
             <a:avLst/>
@@ -1771,6 +1775,118 @@
           </a:p>
         </p:txBody>
       </p:sp>
+      <p:sp>
+        <p:nvSpPr>
+          <p:cNvPr id="7" name="Rectangle 6"/>
+          <p:cNvSpPr/>
+          <p:nvPr/>
+        </p:nvSpPr>
+        <p:spPr>
+          <a:xfrm>
+            <a:off x="7315200" y="0"/>
+            <a:ext cx="4876800" cy="6858000"/>
+          </a:xfrm>
+          <a:prstGeom prst="rect">
+            <a:avLst/>
+          </a:prstGeom>
+          <a:solidFill>
+            <a:srgbClr val="FFFFFF"/>
+          </a:solidFill>
+          <a:ln>
+            <a:noFill/>
+          </a:ln>
+          <a:effectLst/>
+        </p:spPr>
+        <p:style>
+          <a:lnRef idx="1">
+            <a:schemeClr val="accent1"/>
+          </a:lnRef>
+          <a:fillRef idx="3">
+            <a:schemeClr val="accent1"/>
+          </a:fillRef>
+          <a:effectRef idx="2">
+            <a:schemeClr val="accent1"/>
+          </a:effectRef>
+          <a:fontRef idx="minor">
+            <a:schemeClr val="lt1"/>
+          </a:fontRef>
+        </p:style>
+        <p:txBody>
+          <a:bodyPr rtlCol="0" anchor="ctr"/>
+          <a:lstStyle/>
+          <a:p>
+            <a:pPr algn="ctr"/>
+          </a:p>
+        </p:txBody>
+      </p:sp>
+      <p:pic>
+        <p:nvPicPr>
+          <p:cNvPr id="8" name="Picture 7" descr="indulgetix_logo.png"/>
+          <p:cNvPicPr>
+            <a:picLocks noChangeAspect="1"/>
+          </p:cNvPicPr>
+          <p:nvPr/>
+        </p:nvPicPr>
+        <p:blipFill>
+          <a:blip r:embed="rId3"/>
+          <a:stretch>
+            <a:fillRect/>
+          </a:stretch>
+        </p:blipFill>
+        <p:spPr>
+          <a:xfrm>
+            <a:off x="8046720" y="2346929"/>
+            <a:ext cx="3413760" cy="2164142"/>
+          </a:xfrm>
+          <a:prstGeom prst="rect">
+            <a:avLst/>
+          </a:prstGeom>
+        </p:spPr>
+      </p:pic>
+      <p:sp>
+        <p:nvSpPr>
+          <p:cNvPr id="9" name="Rectangle 8"/>
+          <p:cNvSpPr/>
+          <p:nvPr/>
+        </p:nvSpPr>
+        <p:spPr>
+          <a:xfrm>
+            <a:off x="7315200" y="0"/>
+            <a:ext cx="109728" cy="6858000"/>
+          </a:xfrm>
+          <a:prstGeom prst="rect">
+            <a:avLst/>
+          </a:prstGeom>
+          <a:solidFill>
+            <a:srgbClr val="F0561A"/>
+          </a:solidFill>
+          <a:ln>
+            <a:noFill/>
+          </a:ln>
+          <a:effectLst/>
+        </p:spPr>
+        <p:style>
+          <a:lnRef idx="1">
+            <a:schemeClr val="accent1"/>
+          </a:lnRef>
+          <a:fillRef idx="3">
+            <a:schemeClr val="accent1"/>
+          </a:fillRef>
+          <a:effectRef idx="2">
+            <a:schemeClr val="accent1"/>
+          </a:effectRef>
+          <a:fontRef idx="minor">
+            <a:schemeClr val="lt1"/>
+          </a:fontRef>
+        </p:style>
+        <p:txBody>
+          <a:bodyPr rtlCol="0" anchor="ctr"/>
+          <a:lstStyle/>
+          <a:p>
+            <a:pPr algn="ctr"/>
+          </a:p>
+        </p:txBody>
+      </p:sp>
     </p:spTree>
   </p:cSld>
   <p:clrMapOvr>
@@ -1830,7 +1946,7 @@
             <a:r>
               <a:rPr lang="en-US" sz="2600" b="1" dirty="0">
                 <a:solidFill>
-                  <a:srgbClr val="15253D"/>
+                  <a:srgbClr val="201F20"/>
                 </a:solidFill>
                 <a:latin typeface="Arial" pitchFamily="34" charset="0"/>
                 <a:ea typeface="Arial" pitchFamily="34" charset="-122"/>
@@ -1857,11 +1973,11 @@
             <a:avLst/>
           </a:prstGeom>
           <a:solidFill>
-            <a:srgbClr val="F4F7FB"/>
+            <a:srgbClr val="F7F5F4"/>
           </a:solidFill>
           <a:ln w="12700">
             <a:solidFill>
-              <a:srgbClr val="F4F7FB"/>
+              <a:srgbClr val="F7F5F4"/>
             </a:solidFill>
             <a:prstDash val="solid"/>
           </a:ln>
@@ -1894,7 +2010,7 @@
             <a:r>
               <a:rPr lang="en-US" sz="1400" b="1" dirty="0">
                 <a:solidFill>
-                  <a:srgbClr val="0F766E"/>
+                  <a:srgbClr val="D9480F"/>
                 </a:solidFill>
                 <a:latin typeface="Arial" pitchFamily="34" charset="0"/>
                 <a:ea typeface="Arial" pitchFamily="34" charset="-122"/>
@@ -1972,7 +2088,7 @@
             <a:r>
               <a:rPr lang="en-US" sz="1400" b="1" dirty="0">
                 <a:solidFill>
-                  <a:srgbClr val="0F766E"/>
+                  <a:srgbClr val="D9480F"/>
                 </a:solidFill>
                 <a:latin typeface="Arial" pitchFamily="34" charset="0"/>
                 <a:ea typeface="Arial" pitchFamily="34" charset="-122"/>
@@ -1999,11 +2115,11 @@
             <a:avLst/>
           </a:prstGeom>
           <a:solidFill>
-            <a:srgbClr val="EA580C"/>
+            <a:srgbClr val="F0561A"/>
           </a:solidFill>
           <a:ln w="12700">
             <a:solidFill>
-              <a:srgbClr val="EA580C"/>
+              <a:srgbClr val="F0561A"/>
             </a:solidFill>
             <a:prstDash val="solid"/>
           </a:ln>
@@ -2102,11 +2218,11 @@
             <a:avLst/>
           </a:prstGeom>
           <a:solidFill>
-            <a:srgbClr val="EA580C"/>
+            <a:srgbClr val="F0561A"/>
           </a:solidFill>
           <a:ln w="12700">
             <a:solidFill>
-              <a:srgbClr val="EA580C"/>
+              <a:srgbClr val="F0561A"/>
             </a:solidFill>
             <a:prstDash val="solid"/>
           </a:ln>
@@ -2205,11 +2321,11 @@
             <a:avLst/>
           </a:prstGeom>
           <a:solidFill>
-            <a:srgbClr val="EA580C"/>
+            <a:srgbClr val="F0561A"/>
           </a:solidFill>
           <a:ln w="12700">
             <a:solidFill>
-              <a:srgbClr val="EA580C"/>
+              <a:srgbClr val="F0561A"/>
             </a:solidFill>
             <a:prstDash val="solid"/>
           </a:ln>
@@ -2371,6 +2487,118 @@
           </a:p>
         </p:txBody>
       </p:sp>
+      <p:sp>
+        <p:nvSpPr>
+          <p:cNvPr id="18" name="Rectangle 17"/>
+          <p:cNvSpPr/>
+          <p:nvPr/>
+        </p:nvSpPr>
+        <p:spPr>
+          <a:xfrm>
+            <a:off x="0" y="0"/>
+            <a:ext cx="12192000" cy="82296"/>
+          </a:xfrm>
+          <a:prstGeom prst="rect">
+            <a:avLst/>
+          </a:prstGeom>
+          <a:solidFill>
+            <a:srgbClr val="201F20"/>
+          </a:solidFill>
+          <a:ln>
+            <a:noFill/>
+          </a:ln>
+          <a:effectLst/>
+        </p:spPr>
+        <p:style>
+          <a:lnRef idx="1">
+            <a:schemeClr val="accent1"/>
+          </a:lnRef>
+          <a:fillRef idx="3">
+            <a:schemeClr val="accent1"/>
+          </a:fillRef>
+          <a:effectRef idx="2">
+            <a:schemeClr val="accent1"/>
+          </a:effectRef>
+          <a:fontRef idx="minor">
+            <a:schemeClr val="lt1"/>
+          </a:fontRef>
+        </p:style>
+        <p:txBody>
+          <a:bodyPr rtlCol="0" anchor="ctr"/>
+          <a:lstStyle/>
+          <a:p>
+            <a:pPr algn="ctr"/>
+          </a:p>
+        </p:txBody>
+      </p:sp>
+      <p:sp>
+        <p:nvSpPr>
+          <p:cNvPr id="19" name="Rectangle 18"/>
+          <p:cNvSpPr/>
+          <p:nvPr/>
+        </p:nvSpPr>
+        <p:spPr>
+          <a:xfrm>
+            <a:off x="0" y="82296"/>
+            <a:ext cx="1463040" cy="45720"/>
+          </a:xfrm>
+          <a:prstGeom prst="rect">
+            <a:avLst/>
+          </a:prstGeom>
+          <a:solidFill>
+            <a:srgbClr val="F0561A"/>
+          </a:solidFill>
+          <a:ln>
+            <a:noFill/>
+          </a:ln>
+          <a:effectLst/>
+        </p:spPr>
+        <p:style>
+          <a:lnRef idx="1">
+            <a:schemeClr val="accent1"/>
+          </a:lnRef>
+          <a:fillRef idx="3">
+            <a:schemeClr val="accent1"/>
+          </a:fillRef>
+          <a:effectRef idx="2">
+            <a:schemeClr val="accent1"/>
+          </a:effectRef>
+          <a:fontRef idx="minor">
+            <a:schemeClr val="lt1"/>
+          </a:fontRef>
+        </p:style>
+        <p:txBody>
+          <a:bodyPr rtlCol="0" anchor="ctr"/>
+          <a:lstStyle/>
+          <a:p>
+            <a:pPr algn="ctr"/>
+          </a:p>
+        </p:txBody>
+      </p:sp>
+      <p:pic>
+        <p:nvPicPr>
+          <p:cNvPr id="20" name="Picture 19" descr="indulgetix_logo.png"/>
+          <p:cNvPicPr>
+            <a:picLocks noChangeAspect="1"/>
+          </p:cNvPicPr>
+          <p:nvPr/>
+        </p:nvPicPr>
+        <p:blipFill>
+          <a:blip r:embed="rId3"/>
+          <a:stretch>
+            <a:fillRect/>
+          </a:stretch>
+        </p:blipFill>
+        <p:spPr>
+          <a:xfrm>
+            <a:off x="10563218" y="6336792"/>
+            <a:ext cx="605804" cy="384047"/>
+          </a:xfrm>
+          <a:prstGeom prst="rect">
+            <a:avLst/>
+          </a:prstGeom>
+        </p:spPr>
+      </p:pic>
     </p:spTree>
   </p:cSld>
   <p:clrMapOvr>
@@ -2430,7 +2658,7 @@
             <a:r>
               <a:rPr lang="en-US" sz="2600" b="1" dirty="0">
                 <a:solidFill>
-                  <a:srgbClr val="15253D"/>
+                  <a:srgbClr val="201F20"/>
                 </a:solidFill>
                 <a:latin typeface="Arial" pitchFamily="34" charset="0"/>
                 <a:ea typeface="Arial" pitchFamily="34" charset="-122"/>
@@ -2583,6 +2811,118 @@
           </a:p>
         </p:txBody>
       </p:sp>
+      <p:sp>
+        <p:nvSpPr>
+          <p:cNvPr id="7" name="Rectangle 6"/>
+          <p:cNvSpPr/>
+          <p:nvPr/>
+        </p:nvSpPr>
+        <p:spPr>
+          <a:xfrm>
+            <a:off x="0" y="0"/>
+            <a:ext cx="12192000" cy="82296"/>
+          </a:xfrm>
+          <a:prstGeom prst="rect">
+            <a:avLst/>
+          </a:prstGeom>
+          <a:solidFill>
+            <a:srgbClr val="201F20"/>
+          </a:solidFill>
+          <a:ln>
+            <a:noFill/>
+          </a:ln>
+          <a:effectLst/>
+        </p:spPr>
+        <p:style>
+          <a:lnRef idx="1">
+            <a:schemeClr val="accent1"/>
+          </a:lnRef>
+          <a:fillRef idx="3">
+            <a:schemeClr val="accent1"/>
+          </a:fillRef>
+          <a:effectRef idx="2">
+            <a:schemeClr val="accent1"/>
+          </a:effectRef>
+          <a:fontRef idx="minor">
+            <a:schemeClr val="lt1"/>
+          </a:fontRef>
+        </p:style>
+        <p:txBody>
+          <a:bodyPr rtlCol="0" anchor="ctr"/>
+          <a:lstStyle/>
+          <a:p>
+            <a:pPr algn="ctr"/>
+          </a:p>
+        </p:txBody>
+      </p:sp>
+      <p:sp>
+        <p:nvSpPr>
+          <p:cNvPr id="8" name="Rectangle 7"/>
+          <p:cNvSpPr/>
+          <p:nvPr/>
+        </p:nvSpPr>
+        <p:spPr>
+          <a:xfrm>
+            <a:off x="0" y="82296"/>
+            <a:ext cx="1463040" cy="45720"/>
+          </a:xfrm>
+          <a:prstGeom prst="rect">
+            <a:avLst/>
+          </a:prstGeom>
+          <a:solidFill>
+            <a:srgbClr val="F0561A"/>
+          </a:solidFill>
+          <a:ln>
+            <a:noFill/>
+          </a:ln>
+          <a:effectLst/>
+        </p:spPr>
+        <p:style>
+          <a:lnRef idx="1">
+            <a:schemeClr val="accent1"/>
+          </a:lnRef>
+          <a:fillRef idx="3">
+            <a:schemeClr val="accent1"/>
+          </a:fillRef>
+          <a:effectRef idx="2">
+            <a:schemeClr val="accent1"/>
+          </a:effectRef>
+          <a:fontRef idx="minor">
+            <a:schemeClr val="lt1"/>
+          </a:fontRef>
+        </p:style>
+        <p:txBody>
+          <a:bodyPr rtlCol="0" anchor="ctr"/>
+          <a:lstStyle/>
+          <a:p>
+            <a:pPr algn="ctr"/>
+          </a:p>
+        </p:txBody>
+      </p:sp>
+      <p:pic>
+        <p:nvPicPr>
+          <p:cNvPr id="9" name="Picture 8" descr="indulgetix_logo.png"/>
+          <p:cNvPicPr>
+            <a:picLocks noChangeAspect="1"/>
+          </p:cNvPicPr>
+          <p:nvPr/>
+        </p:nvPicPr>
+        <p:blipFill>
+          <a:blip r:embed="rId4"/>
+          <a:stretch>
+            <a:fillRect/>
+          </a:stretch>
+        </p:blipFill>
+        <p:spPr>
+          <a:xfrm>
+            <a:off x="10563218" y="6336792"/>
+            <a:ext cx="605804" cy="384047"/>
+          </a:xfrm>
+          <a:prstGeom prst="rect">
+            <a:avLst/>
+          </a:prstGeom>
+        </p:spPr>
+      </p:pic>
     </p:spTree>
   </p:cSld>
   <p:clrMapOvr>
@@ -2642,7 +2982,7 @@
             <a:r>
               <a:rPr lang="en-US" sz="2600" b="1" dirty="0">
                 <a:solidFill>
-                  <a:srgbClr val="15253D"/>
+                  <a:srgbClr val="201F20"/>
                 </a:solidFill>
                 <a:latin typeface="Arial" pitchFamily="34" charset="0"/>
                 <a:ea typeface="Arial" pitchFamily="34" charset="-122"/>
@@ -2795,6 +3135,118 @@
           </a:p>
         </p:txBody>
       </p:sp>
+      <p:sp>
+        <p:nvSpPr>
+          <p:cNvPr id="7" name="Rectangle 6"/>
+          <p:cNvSpPr/>
+          <p:nvPr/>
+        </p:nvSpPr>
+        <p:spPr>
+          <a:xfrm>
+            <a:off x="0" y="0"/>
+            <a:ext cx="12192000" cy="82296"/>
+          </a:xfrm>
+          <a:prstGeom prst="rect">
+            <a:avLst/>
+          </a:prstGeom>
+          <a:solidFill>
+            <a:srgbClr val="201F20"/>
+          </a:solidFill>
+          <a:ln>
+            <a:noFill/>
+          </a:ln>
+          <a:effectLst/>
+        </p:spPr>
+        <p:style>
+          <a:lnRef idx="1">
+            <a:schemeClr val="accent1"/>
+          </a:lnRef>
+          <a:fillRef idx="3">
+            <a:schemeClr val="accent1"/>
+          </a:fillRef>
+          <a:effectRef idx="2">
+            <a:schemeClr val="accent1"/>
+          </a:effectRef>
+          <a:fontRef idx="minor">
+            <a:schemeClr val="lt1"/>
+          </a:fontRef>
+        </p:style>
+        <p:txBody>
+          <a:bodyPr rtlCol="0" anchor="ctr"/>
+          <a:lstStyle/>
+          <a:p>
+            <a:pPr algn="ctr"/>
+          </a:p>
+        </p:txBody>
+      </p:sp>
+      <p:sp>
+        <p:nvSpPr>
+          <p:cNvPr id="8" name="Rectangle 7"/>
+          <p:cNvSpPr/>
+          <p:nvPr/>
+        </p:nvSpPr>
+        <p:spPr>
+          <a:xfrm>
+            <a:off x="0" y="82296"/>
+            <a:ext cx="1463040" cy="45720"/>
+          </a:xfrm>
+          <a:prstGeom prst="rect">
+            <a:avLst/>
+          </a:prstGeom>
+          <a:solidFill>
+            <a:srgbClr val="F0561A"/>
+          </a:solidFill>
+          <a:ln>
+            <a:noFill/>
+          </a:ln>
+          <a:effectLst/>
+        </p:spPr>
+        <p:style>
+          <a:lnRef idx="1">
+            <a:schemeClr val="accent1"/>
+          </a:lnRef>
+          <a:fillRef idx="3">
+            <a:schemeClr val="accent1"/>
+          </a:fillRef>
+          <a:effectRef idx="2">
+            <a:schemeClr val="accent1"/>
+          </a:effectRef>
+          <a:fontRef idx="minor">
+            <a:schemeClr val="lt1"/>
+          </a:fontRef>
+        </p:style>
+        <p:txBody>
+          <a:bodyPr rtlCol="0" anchor="ctr"/>
+          <a:lstStyle/>
+          <a:p>
+            <a:pPr algn="ctr"/>
+          </a:p>
+        </p:txBody>
+      </p:sp>
+      <p:pic>
+        <p:nvPicPr>
+          <p:cNvPr id="9" name="Picture 8" descr="indulgetix_logo.png"/>
+          <p:cNvPicPr>
+            <a:picLocks noChangeAspect="1"/>
+          </p:cNvPicPr>
+          <p:nvPr/>
+        </p:nvPicPr>
+        <p:blipFill>
+          <a:blip r:embed="rId4"/>
+          <a:stretch>
+            <a:fillRect/>
+          </a:stretch>
+        </p:blipFill>
+        <p:spPr>
+          <a:xfrm>
+            <a:off x="10563218" y="6336792"/>
+            <a:ext cx="605804" cy="384047"/>
+          </a:xfrm>
+          <a:prstGeom prst="rect">
+            <a:avLst/>
+          </a:prstGeom>
+        </p:spPr>
+      </p:pic>
     </p:spTree>
   </p:cSld>
   <p:clrMapOvr>
@@ -2854,7 +3306,7 @@
             <a:r>
               <a:rPr lang="en-US" sz="2600" b="1" dirty="0">
                 <a:solidFill>
-                  <a:srgbClr val="15253D"/>
+                  <a:srgbClr val="201F20"/>
                 </a:solidFill>
                 <a:latin typeface="Arial" pitchFamily="34" charset="0"/>
                 <a:ea typeface="Arial" pitchFamily="34" charset="-122"/>
@@ -3007,6 +3459,118 @@
           </a:p>
         </p:txBody>
       </p:sp>
+      <p:sp>
+        <p:nvSpPr>
+          <p:cNvPr id="7" name="Rectangle 6"/>
+          <p:cNvSpPr/>
+          <p:nvPr/>
+        </p:nvSpPr>
+        <p:spPr>
+          <a:xfrm>
+            <a:off x="0" y="0"/>
+            <a:ext cx="12192000" cy="82296"/>
+          </a:xfrm>
+          <a:prstGeom prst="rect">
+            <a:avLst/>
+          </a:prstGeom>
+          <a:solidFill>
+            <a:srgbClr val="201F20"/>
+          </a:solidFill>
+          <a:ln>
+            <a:noFill/>
+          </a:ln>
+          <a:effectLst/>
+        </p:spPr>
+        <p:style>
+          <a:lnRef idx="1">
+            <a:schemeClr val="accent1"/>
+          </a:lnRef>
+          <a:fillRef idx="3">
+            <a:schemeClr val="accent1"/>
+          </a:fillRef>
+          <a:effectRef idx="2">
+            <a:schemeClr val="accent1"/>
+          </a:effectRef>
+          <a:fontRef idx="minor">
+            <a:schemeClr val="lt1"/>
+          </a:fontRef>
+        </p:style>
+        <p:txBody>
+          <a:bodyPr rtlCol="0" anchor="ctr"/>
+          <a:lstStyle/>
+          <a:p>
+            <a:pPr algn="ctr"/>
+          </a:p>
+        </p:txBody>
+      </p:sp>
+      <p:sp>
+        <p:nvSpPr>
+          <p:cNvPr id="8" name="Rectangle 7"/>
+          <p:cNvSpPr/>
+          <p:nvPr/>
+        </p:nvSpPr>
+        <p:spPr>
+          <a:xfrm>
+            <a:off x="0" y="82296"/>
+            <a:ext cx="1463040" cy="45720"/>
+          </a:xfrm>
+          <a:prstGeom prst="rect">
+            <a:avLst/>
+          </a:prstGeom>
+          <a:solidFill>
+            <a:srgbClr val="F0561A"/>
+          </a:solidFill>
+          <a:ln>
+            <a:noFill/>
+          </a:ln>
+          <a:effectLst/>
+        </p:spPr>
+        <p:style>
+          <a:lnRef idx="1">
+            <a:schemeClr val="accent1"/>
+          </a:lnRef>
+          <a:fillRef idx="3">
+            <a:schemeClr val="accent1"/>
+          </a:fillRef>
+          <a:effectRef idx="2">
+            <a:schemeClr val="accent1"/>
+          </a:effectRef>
+          <a:fontRef idx="minor">
+            <a:schemeClr val="lt1"/>
+          </a:fontRef>
+        </p:style>
+        <p:txBody>
+          <a:bodyPr rtlCol="0" anchor="ctr"/>
+          <a:lstStyle/>
+          <a:p>
+            <a:pPr algn="ctr"/>
+          </a:p>
+        </p:txBody>
+      </p:sp>
+      <p:pic>
+        <p:nvPicPr>
+          <p:cNvPr id="9" name="Picture 8" descr="indulgetix_logo.png"/>
+          <p:cNvPicPr>
+            <a:picLocks noChangeAspect="1"/>
+          </p:cNvPicPr>
+          <p:nvPr/>
+        </p:nvPicPr>
+        <p:blipFill>
+          <a:blip r:embed="rId4"/>
+          <a:stretch>
+            <a:fillRect/>
+          </a:stretch>
+        </p:blipFill>
+        <p:spPr>
+          <a:xfrm>
+            <a:off x="10563218" y="6336792"/>
+            <a:ext cx="605804" cy="384047"/>
+          </a:xfrm>
+          <a:prstGeom prst="rect">
+            <a:avLst/>
+          </a:prstGeom>
+        </p:spPr>
+      </p:pic>
     </p:spTree>
   </p:cSld>
   <p:clrMapOvr>
@@ -3066,7 +3630,7 @@
             <a:r>
               <a:rPr lang="en-US" sz="2600" b="1" dirty="0">
                 <a:solidFill>
-                  <a:srgbClr val="15253D"/>
+                  <a:srgbClr val="201F20"/>
                 </a:solidFill>
                 <a:latin typeface="Arial" pitchFamily="34" charset="0"/>
                 <a:ea typeface="Arial" pitchFamily="34" charset="-122"/>
@@ -3135,7 +3699,7 @@
                   <a:tcPr marL="109728" marR="109728" marT="109728" marB="109728" anchor="ctr">
                     <a:lnL w="9525" cap="flat" cmpd="sng" algn="ctr">
                       <a:solidFill>
-                        <a:srgbClr val="D5DDE8"/>
+                        <a:srgbClr val="E4DFDC"/>
                       </a:solidFill>
                       <a:prstDash val="solid"/>
                       <a:round/>
@@ -3144,7 +3708,7 @@
                     </a:lnL>
                     <a:lnR w="9525" cap="flat" cmpd="sng" algn="ctr">
                       <a:solidFill>
-                        <a:srgbClr val="D5DDE8"/>
+                        <a:srgbClr val="E4DFDC"/>
                       </a:solidFill>
                       <a:prstDash val="solid"/>
                       <a:round/>
@@ -3153,7 +3717,7 @@
                     </a:lnR>
                     <a:lnT w="9525" cap="flat" cmpd="sng" algn="ctr">
                       <a:solidFill>
-                        <a:srgbClr val="D5DDE8"/>
+                        <a:srgbClr val="E4DFDC"/>
                       </a:solidFill>
                       <a:prstDash val="solid"/>
                       <a:round/>
@@ -3162,7 +3726,7 @@
                     </a:lnT>
                     <a:lnB w="9525" cap="flat" cmpd="sng" algn="ctr">
                       <a:solidFill>
-                        <a:srgbClr val="D5DDE8"/>
+                        <a:srgbClr val="E4DFDC"/>
                       </a:solidFill>
                       <a:prstDash val="solid"/>
                       <a:round/>
@@ -3170,7 +3734,7 @@
                       <a:tailEnd type="none" w="med" len="med"/>
                     </a:lnB>
                     <a:solidFill>
-                      <a:srgbClr val="15253D"/>
+                      <a:srgbClr val="201F20"/>
                     </a:solidFill>
                   </a:tcPr>
                 </a:tc>
@@ -3203,7 +3767,7 @@
                   <a:tcPr marL="109728" marR="109728" marT="109728" marB="109728" anchor="ctr">
                     <a:lnL w="9525" cap="flat" cmpd="sng" algn="ctr">
                       <a:solidFill>
-                        <a:srgbClr val="D5DDE8"/>
+                        <a:srgbClr val="E4DFDC"/>
                       </a:solidFill>
                       <a:prstDash val="solid"/>
                       <a:round/>
@@ -3212,7 +3776,7 @@
                     </a:lnL>
                     <a:lnR w="9525" cap="flat" cmpd="sng" algn="ctr">
                       <a:solidFill>
-                        <a:srgbClr val="D5DDE8"/>
+                        <a:srgbClr val="E4DFDC"/>
                       </a:solidFill>
                       <a:prstDash val="solid"/>
                       <a:round/>
@@ -3221,7 +3785,7 @@
                     </a:lnR>
                     <a:lnT w="9525" cap="flat" cmpd="sng" algn="ctr">
                       <a:solidFill>
-                        <a:srgbClr val="D5DDE8"/>
+                        <a:srgbClr val="E4DFDC"/>
                       </a:solidFill>
                       <a:prstDash val="solid"/>
                       <a:round/>
@@ -3230,7 +3794,7 @@
                     </a:lnT>
                     <a:lnB w="9525" cap="flat" cmpd="sng" algn="ctr">
                       <a:solidFill>
-                        <a:srgbClr val="D5DDE8"/>
+                        <a:srgbClr val="E4DFDC"/>
                       </a:solidFill>
                       <a:prstDash val="solid"/>
                       <a:round/>
@@ -3238,7 +3802,7 @@
                       <a:tailEnd type="none" w="med" len="med"/>
                     </a:lnB>
                     <a:solidFill>
-                      <a:srgbClr val="15253D"/>
+                      <a:srgbClr val="201F20"/>
                     </a:solidFill>
                   </a:tcPr>
                 </a:tc>
@@ -3271,7 +3835,7 @@
                   <a:tcPr marL="109728" marR="109728" marT="109728" marB="109728" anchor="ctr">
                     <a:lnL w="9525" cap="flat" cmpd="sng" algn="ctr">
                       <a:solidFill>
-                        <a:srgbClr val="D5DDE8"/>
+                        <a:srgbClr val="E4DFDC"/>
                       </a:solidFill>
                       <a:prstDash val="solid"/>
                       <a:round/>
@@ -3280,7 +3844,7 @@
                     </a:lnL>
                     <a:lnR w="9525" cap="flat" cmpd="sng" algn="ctr">
                       <a:solidFill>
-                        <a:srgbClr val="D5DDE8"/>
+                        <a:srgbClr val="E4DFDC"/>
                       </a:solidFill>
                       <a:prstDash val="solid"/>
                       <a:round/>
@@ -3289,7 +3853,7 @@
                     </a:lnR>
                     <a:lnT w="9525" cap="flat" cmpd="sng" algn="ctr">
                       <a:solidFill>
-                        <a:srgbClr val="D5DDE8"/>
+                        <a:srgbClr val="E4DFDC"/>
                       </a:solidFill>
                       <a:prstDash val="solid"/>
                       <a:round/>
@@ -3298,7 +3862,7 @@
                     </a:lnT>
                     <a:lnB w="9525" cap="flat" cmpd="sng" algn="ctr">
                       <a:solidFill>
-                        <a:srgbClr val="D5DDE8"/>
+                        <a:srgbClr val="E4DFDC"/>
                       </a:solidFill>
                       <a:prstDash val="solid"/>
                       <a:round/>
@@ -3306,7 +3870,7 @@
                       <a:tailEnd type="none" w="med" len="med"/>
                     </a:lnB>
                     <a:solidFill>
-                      <a:srgbClr val="15253D"/>
+                      <a:srgbClr val="201F20"/>
                     </a:solidFill>
                   </a:tcPr>
                 </a:tc>
@@ -3323,7 +3887,7 @@
                       <a:r>
                         <a:rPr lang="en-US" sz="1500" b="1" dirty="0">
                           <a:solidFill>
-                            <a:srgbClr val="0F766E"/>
+                            <a:srgbClr val="D9480F"/>
                           </a:solidFill>
                           <a:latin typeface="Arial" pitchFamily="34" charset="0"/>
                           <a:ea typeface="Arial" pitchFamily="34" charset="-122"/>
@@ -3341,7 +3905,7 @@
                   <a:tcPr marL="109728" marR="109728" marT="109728" marB="109728" anchor="ctr">
                     <a:lnL w="9525" cap="flat" cmpd="sng" algn="ctr">
                       <a:solidFill>
-                        <a:srgbClr val="D5DDE8"/>
+                        <a:srgbClr val="E4DFDC"/>
                       </a:solidFill>
                       <a:prstDash val="solid"/>
                       <a:round/>
@@ -3350,7 +3914,7 @@
                     </a:lnL>
                     <a:lnR w="9525" cap="flat" cmpd="sng" algn="ctr">
                       <a:solidFill>
-                        <a:srgbClr val="D5DDE8"/>
+                        <a:srgbClr val="E4DFDC"/>
                       </a:solidFill>
                       <a:prstDash val="solid"/>
                       <a:round/>
@@ -3359,7 +3923,7 @@
                     </a:lnR>
                     <a:lnT w="9525" cap="flat" cmpd="sng" algn="ctr">
                       <a:solidFill>
-                        <a:srgbClr val="D5DDE8"/>
+                        <a:srgbClr val="E4DFDC"/>
                       </a:solidFill>
                       <a:prstDash val="solid"/>
                       <a:round/>
@@ -3368,7 +3932,7 @@
                     </a:lnT>
                     <a:lnB w="9525" cap="flat" cmpd="sng" algn="ctr">
                       <a:solidFill>
-                        <a:srgbClr val="D5DDE8"/>
+                        <a:srgbClr val="E4DFDC"/>
                       </a:solidFill>
                       <a:prstDash val="solid"/>
                       <a:round/>
@@ -3376,7 +3940,7 @@
                       <a:tailEnd type="none" w="med" len="med"/>
                     </a:lnB>
                     <a:solidFill>
-                      <a:srgbClr val="F4F7FB"/>
+                      <a:srgbClr val="F7F5F4"/>
                     </a:solidFill>
                   </a:tcPr>
                 </a:tc>
@@ -3409,7 +3973,7 @@
                   <a:tcPr marL="109728" marR="109728" marT="109728" marB="109728" anchor="ctr">
                     <a:lnL w="9525" cap="flat" cmpd="sng" algn="ctr">
                       <a:solidFill>
-                        <a:srgbClr val="D5DDE8"/>
+                        <a:srgbClr val="E4DFDC"/>
                       </a:solidFill>
                       <a:prstDash val="solid"/>
                       <a:round/>
@@ -3418,7 +3982,7 @@
                     </a:lnL>
                     <a:lnR w="9525" cap="flat" cmpd="sng" algn="ctr">
                       <a:solidFill>
-                        <a:srgbClr val="D5DDE8"/>
+                        <a:srgbClr val="E4DFDC"/>
                       </a:solidFill>
                       <a:prstDash val="solid"/>
                       <a:round/>
@@ -3427,7 +3991,7 @@
                     </a:lnR>
                     <a:lnT w="9525" cap="flat" cmpd="sng" algn="ctr">
                       <a:solidFill>
-                        <a:srgbClr val="D5DDE8"/>
+                        <a:srgbClr val="E4DFDC"/>
                       </a:solidFill>
                       <a:prstDash val="solid"/>
                       <a:round/>
@@ -3436,7 +4000,7 @@
                     </a:lnT>
                     <a:lnB w="9525" cap="flat" cmpd="sng" algn="ctr">
                       <a:solidFill>
-                        <a:srgbClr val="D5DDE8"/>
+                        <a:srgbClr val="E4DFDC"/>
                       </a:solidFill>
                       <a:prstDash val="solid"/>
                       <a:round/>
@@ -3444,7 +4008,7 @@
                       <a:tailEnd type="none" w="med" len="med"/>
                     </a:lnB>
                     <a:solidFill>
-                      <a:srgbClr val="F4F7FB"/>
+                      <a:srgbClr val="F7F5F4"/>
                     </a:solidFill>
                   </a:tcPr>
                 </a:tc>
@@ -3477,7 +4041,7 @@
                   <a:tcPr marL="109728" marR="109728" marT="109728" marB="109728" anchor="ctr">
                     <a:lnL w="9525" cap="flat" cmpd="sng" algn="ctr">
                       <a:solidFill>
-                        <a:srgbClr val="D5DDE8"/>
+                        <a:srgbClr val="E4DFDC"/>
                       </a:solidFill>
                       <a:prstDash val="solid"/>
                       <a:round/>
@@ -3486,7 +4050,7 @@
                     </a:lnL>
                     <a:lnR w="9525" cap="flat" cmpd="sng" algn="ctr">
                       <a:solidFill>
-                        <a:srgbClr val="D5DDE8"/>
+                        <a:srgbClr val="E4DFDC"/>
                       </a:solidFill>
                       <a:prstDash val="solid"/>
                       <a:round/>
@@ -3495,7 +4059,7 @@
                     </a:lnR>
                     <a:lnT w="9525" cap="flat" cmpd="sng" algn="ctr">
                       <a:solidFill>
-                        <a:srgbClr val="D5DDE8"/>
+                        <a:srgbClr val="E4DFDC"/>
                       </a:solidFill>
                       <a:prstDash val="solid"/>
                       <a:round/>
@@ -3504,7 +4068,7 @@
                     </a:lnT>
                     <a:lnB w="9525" cap="flat" cmpd="sng" algn="ctr">
                       <a:solidFill>
-                        <a:srgbClr val="D5DDE8"/>
+                        <a:srgbClr val="E4DFDC"/>
                       </a:solidFill>
                       <a:prstDash val="solid"/>
                       <a:round/>
@@ -3512,7 +4076,7 @@
                       <a:tailEnd type="none" w="med" len="med"/>
                     </a:lnB>
                     <a:solidFill>
-                      <a:srgbClr val="F4F7FB"/>
+                      <a:srgbClr val="F7F5F4"/>
                     </a:solidFill>
                   </a:tcPr>
                 </a:tc>
@@ -3529,7 +4093,7 @@
                       <a:r>
                         <a:rPr lang="en-US" sz="1500" b="1" dirty="0">
                           <a:solidFill>
-                            <a:srgbClr val="0F766E"/>
+                            <a:srgbClr val="D9480F"/>
                           </a:solidFill>
                           <a:latin typeface="Arial" pitchFamily="34" charset="0"/>
                           <a:ea typeface="Arial" pitchFamily="34" charset="-122"/>
@@ -3547,7 +4111,7 @@
                   <a:tcPr marL="109728" marR="109728" marT="109728" marB="109728" anchor="ctr">
                     <a:lnL w="9525" cap="flat" cmpd="sng" algn="ctr">
                       <a:solidFill>
-                        <a:srgbClr val="D5DDE8"/>
+                        <a:srgbClr val="E4DFDC"/>
                       </a:solidFill>
                       <a:prstDash val="solid"/>
                       <a:round/>
@@ -3556,7 +4120,7 @@
                     </a:lnL>
                     <a:lnR w="9525" cap="flat" cmpd="sng" algn="ctr">
                       <a:solidFill>
-                        <a:srgbClr val="D5DDE8"/>
+                        <a:srgbClr val="E4DFDC"/>
                       </a:solidFill>
                       <a:prstDash val="solid"/>
                       <a:round/>
@@ -3565,7 +4129,7 @@
                     </a:lnR>
                     <a:lnT w="9525" cap="flat" cmpd="sng" algn="ctr">
                       <a:solidFill>
-                        <a:srgbClr val="D5DDE8"/>
+                        <a:srgbClr val="E4DFDC"/>
                       </a:solidFill>
                       <a:prstDash val="solid"/>
                       <a:round/>
@@ -3574,7 +4138,7 @@
                     </a:lnT>
                     <a:lnB w="9525" cap="flat" cmpd="sng" algn="ctr">
                       <a:solidFill>
-                        <a:srgbClr val="D5DDE8"/>
+                        <a:srgbClr val="E4DFDC"/>
                       </a:solidFill>
                       <a:prstDash val="solid"/>
                       <a:round/>
@@ -3615,7 +4179,7 @@
                   <a:tcPr marL="109728" marR="109728" marT="109728" marB="109728" anchor="ctr">
                     <a:lnL w="9525" cap="flat" cmpd="sng" algn="ctr">
                       <a:solidFill>
-                        <a:srgbClr val="D5DDE8"/>
+                        <a:srgbClr val="E4DFDC"/>
                       </a:solidFill>
                       <a:prstDash val="solid"/>
                       <a:round/>
@@ -3624,7 +4188,7 @@
                     </a:lnL>
                     <a:lnR w="9525" cap="flat" cmpd="sng" algn="ctr">
                       <a:solidFill>
-                        <a:srgbClr val="D5DDE8"/>
+                        <a:srgbClr val="E4DFDC"/>
                       </a:solidFill>
                       <a:prstDash val="solid"/>
                       <a:round/>
@@ -3633,7 +4197,7 @@
                     </a:lnR>
                     <a:lnT w="9525" cap="flat" cmpd="sng" algn="ctr">
                       <a:solidFill>
-                        <a:srgbClr val="D5DDE8"/>
+                        <a:srgbClr val="E4DFDC"/>
                       </a:solidFill>
                       <a:prstDash val="solid"/>
                       <a:round/>
@@ -3642,7 +4206,7 @@
                     </a:lnT>
                     <a:lnB w="9525" cap="flat" cmpd="sng" algn="ctr">
                       <a:solidFill>
-                        <a:srgbClr val="D5DDE8"/>
+                        <a:srgbClr val="E4DFDC"/>
                       </a:solidFill>
                       <a:prstDash val="solid"/>
                       <a:round/>
@@ -3683,7 +4247,7 @@
                   <a:tcPr marL="109728" marR="109728" marT="109728" marB="109728" anchor="ctr">
                     <a:lnL w="9525" cap="flat" cmpd="sng" algn="ctr">
                       <a:solidFill>
-                        <a:srgbClr val="D5DDE8"/>
+                        <a:srgbClr val="E4DFDC"/>
                       </a:solidFill>
                       <a:prstDash val="solid"/>
                       <a:round/>
@@ -3692,7 +4256,7 @@
                     </a:lnL>
                     <a:lnR w="9525" cap="flat" cmpd="sng" algn="ctr">
                       <a:solidFill>
-                        <a:srgbClr val="D5DDE8"/>
+                        <a:srgbClr val="E4DFDC"/>
                       </a:solidFill>
                       <a:prstDash val="solid"/>
                       <a:round/>
@@ -3701,7 +4265,7 @@
                     </a:lnR>
                     <a:lnT w="9525" cap="flat" cmpd="sng" algn="ctr">
                       <a:solidFill>
-                        <a:srgbClr val="D5DDE8"/>
+                        <a:srgbClr val="E4DFDC"/>
                       </a:solidFill>
                       <a:prstDash val="solid"/>
                       <a:round/>
@@ -3710,7 +4274,7 @@
                     </a:lnT>
                     <a:lnB w="9525" cap="flat" cmpd="sng" algn="ctr">
                       <a:solidFill>
-                        <a:srgbClr val="D5DDE8"/>
+                        <a:srgbClr val="E4DFDC"/>
                       </a:solidFill>
                       <a:prstDash val="solid"/>
                       <a:round/>
@@ -3735,7 +4299,7 @@
                       <a:r>
                         <a:rPr lang="en-US" sz="1500" b="1" dirty="0">
                           <a:solidFill>
-                            <a:srgbClr val="0F766E"/>
+                            <a:srgbClr val="D9480F"/>
                           </a:solidFill>
                           <a:latin typeface="Arial" pitchFamily="34" charset="0"/>
                           <a:ea typeface="Arial" pitchFamily="34" charset="-122"/>
@@ -3753,7 +4317,7 @@
                   <a:tcPr marL="109728" marR="109728" marT="109728" marB="109728" anchor="ctr">
                     <a:lnL w="9525" cap="flat" cmpd="sng" algn="ctr">
                       <a:solidFill>
-                        <a:srgbClr val="D5DDE8"/>
+                        <a:srgbClr val="E4DFDC"/>
                       </a:solidFill>
                       <a:prstDash val="solid"/>
                       <a:round/>
@@ -3762,7 +4326,7 @@
                     </a:lnL>
                     <a:lnR w="9525" cap="flat" cmpd="sng" algn="ctr">
                       <a:solidFill>
-                        <a:srgbClr val="D5DDE8"/>
+                        <a:srgbClr val="E4DFDC"/>
                       </a:solidFill>
                       <a:prstDash val="solid"/>
                       <a:round/>
@@ -3771,7 +4335,7 @@
                     </a:lnR>
                     <a:lnT w="9525" cap="flat" cmpd="sng" algn="ctr">
                       <a:solidFill>
-                        <a:srgbClr val="D5DDE8"/>
+                        <a:srgbClr val="E4DFDC"/>
                       </a:solidFill>
                       <a:prstDash val="solid"/>
                       <a:round/>
@@ -3780,7 +4344,7 @@
                     </a:lnT>
                     <a:lnB w="9525" cap="flat" cmpd="sng" algn="ctr">
                       <a:solidFill>
-                        <a:srgbClr val="D5DDE8"/>
+                        <a:srgbClr val="E4DFDC"/>
                       </a:solidFill>
                       <a:prstDash val="solid"/>
                       <a:round/>
@@ -3788,7 +4352,7 @@
                       <a:tailEnd type="none" w="med" len="med"/>
                     </a:lnB>
                     <a:solidFill>
-                      <a:srgbClr val="F4F7FB"/>
+                      <a:srgbClr val="F7F5F4"/>
                     </a:solidFill>
                   </a:tcPr>
                 </a:tc>
@@ -3821,7 +4385,7 @@
                   <a:tcPr marL="109728" marR="109728" marT="109728" marB="109728" anchor="ctr">
                     <a:lnL w="9525" cap="flat" cmpd="sng" algn="ctr">
                       <a:solidFill>
-                        <a:srgbClr val="D5DDE8"/>
+                        <a:srgbClr val="E4DFDC"/>
                       </a:solidFill>
                       <a:prstDash val="solid"/>
                       <a:round/>
@@ -3830,7 +4394,7 @@
                     </a:lnL>
                     <a:lnR w="9525" cap="flat" cmpd="sng" algn="ctr">
                       <a:solidFill>
-                        <a:srgbClr val="D5DDE8"/>
+                        <a:srgbClr val="E4DFDC"/>
                       </a:solidFill>
                       <a:prstDash val="solid"/>
                       <a:round/>
@@ -3839,7 +4403,7 @@
                     </a:lnR>
                     <a:lnT w="9525" cap="flat" cmpd="sng" algn="ctr">
                       <a:solidFill>
-                        <a:srgbClr val="D5DDE8"/>
+                        <a:srgbClr val="E4DFDC"/>
                       </a:solidFill>
                       <a:prstDash val="solid"/>
                       <a:round/>
@@ -3848,7 +4412,7 @@
                     </a:lnT>
                     <a:lnB w="9525" cap="flat" cmpd="sng" algn="ctr">
                       <a:solidFill>
-                        <a:srgbClr val="D5DDE8"/>
+                        <a:srgbClr val="E4DFDC"/>
                       </a:solidFill>
                       <a:prstDash val="solid"/>
                       <a:round/>
@@ -3856,7 +4420,7 @@
                       <a:tailEnd type="none" w="med" len="med"/>
                     </a:lnB>
                     <a:solidFill>
-                      <a:srgbClr val="F4F7FB"/>
+                      <a:srgbClr val="F7F5F4"/>
                     </a:solidFill>
                   </a:tcPr>
                 </a:tc>
@@ -3889,7 +4453,7 @@
                   <a:tcPr marL="109728" marR="109728" marT="109728" marB="109728" anchor="ctr">
                     <a:lnL w="9525" cap="flat" cmpd="sng" algn="ctr">
                       <a:solidFill>
-                        <a:srgbClr val="D5DDE8"/>
+                        <a:srgbClr val="E4DFDC"/>
                       </a:solidFill>
                       <a:prstDash val="solid"/>
                       <a:round/>
@@ -3898,7 +4462,7 @@
                     </a:lnL>
                     <a:lnR w="9525" cap="flat" cmpd="sng" algn="ctr">
                       <a:solidFill>
-                        <a:srgbClr val="D5DDE8"/>
+                        <a:srgbClr val="E4DFDC"/>
                       </a:solidFill>
                       <a:prstDash val="solid"/>
                       <a:round/>
@@ -3907,7 +4471,7 @@
                     </a:lnR>
                     <a:lnT w="9525" cap="flat" cmpd="sng" algn="ctr">
                       <a:solidFill>
-                        <a:srgbClr val="D5DDE8"/>
+                        <a:srgbClr val="E4DFDC"/>
                       </a:solidFill>
                       <a:prstDash val="solid"/>
                       <a:round/>
@@ -3916,7 +4480,7 @@
                     </a:lnT>
                     <a:lnB w="9525" cap="flat" cmpd="sng" algn="ctr">
                       <a:solidFill>
-                        <a:srgbClr val="D5DDE8"/>
+                        <a:srgbClr val="E4DFDC"/>
                       </a:solidFill>
                       <a:prstDash val="solid"/>
                       <a:round/>
@@ -3924,7 +4488,7 @@
                       <a:tailEnd type="none" w="med" len="med"/>
                     </a:lnB>
                     <a:solidFill>
-                      <a:srgbClr val="F4F7FB"/>
+                      <a:srgbClr val="F7F5F4"/>
                     </a:solidFill>
                   </a:tcPr>
                 </a:tc>
@@ -3941,7 +4505,7 @@
                       <a:r>
                         <a:rPr lang="en-US" sz="1500" b="1" dirty="0">
                           <a:solidFill>
-                            <a:srgbClr val="0F766E"/>
+                            <a:srgbClr val="D9480F"/>
                           </a:solidFill>
                           <a:latin typeface="Arial" pitchFamily="34" charset="0"/>
                           <a:ea typeface="Arial" pitchFamily="34" charset="-122"/>
@@ -3959,7 +4523,7 @@
                   <a:tcPr marL="109728" marR="109728" marT="109728" marB="109728" anchor="ctr">
                     <a:lnL w="9525" cap="flat" cmpd="sng" algn="ctr">
                       <a:solidFill>
-                        <a:srgbClr val="D5DDE8"/>
+                        <a:srgbClr val="E4DFDC"/>
                       </a:solidFill>
                       <a:prstDash val="solid"/>
                       <a:round/>
@@ -3968,7 +4532,7 @@
                     </a:lnL>
                     <a:lnR w="9525" cap="flat" cmpd="sng" algn="ctr">
                       <a:solidFill>
-                        <a:srgbClr val="D5DDE8"/>
+                        <a:srgbClr val="E4DFDC"/>
                       </a:solidFill>
                       <a:prstDash val="solid"/>
                       <a:round/>
@@ -3977,7 +4541,7 @@
                     </a:lnR>
                     <a:lnT w="9525" cap="flat" cmpd="sng" algn="ctr">
                       <a:solidFill>
-                        <a:srgbClr val="D5DDE8"/>
+                        <a:srgbClr val="E4DFDC"/>
                       </a:solidFill>
                       <a:prstDash val="solid"/>
                       <a:round/>
@@ -3986,7 +4550,7 @@
                     </a:lnT>
                     <a:lnB w="9525" cap="flat" cmpd="sng" algn="ctr">
                       <a:solidFill>
-                        <a:srgbClr val="D5DDE8"/>
+                        <a:srgbClr val="E4DFDC"/>
                       </a:solidFill>
                       <a:prstDash val="solid"/>
                       <a:round/>
@@ -4027,7 +4591,7 @@
                   <a:tcPr marL="109728" marR="109728" marT="109728" marB="109728" anchor="ctr">
                     <a:lnL w="9525" cap="flat" cmpd="sng" algn="ctr">
                       <a:solidFill>
-                        <a:srgbClr val="D5DDE8"/>
+                        <a:srgbClr val="E4DFDC"/>
                       </a:solidFill>
                       <a:prstDash val="solid"/>
                       <a:round/>
@@ -4036,7 +4600,7 @@
                     </a:lnL>
                     <a:lnR w="9525" cap="flat" cmpd="sng" algn="ctr">
                       <a:solidFill>
-                        <a:srgbClr val="D5DDE8"/>
+                        <a:srgbClr val="E4DFDC"/>
                       </a:solidFill>
                       <a:prstDash val="solid"/>
                       <a:round/>
@@ -4045,7 +4609,7 @@
                     </a:lnR>
                     <a:lnT w="9525" cap="flat" cmpd="sng" algn="ctr">
                       <a:solidFill>
-                        <a:srgbClr val="D5DDE8"/>
+                        <a:srgbClr val="E4DFDC"/>
                       </a:solidFill>
                       <a:prstDash val="solid"/>
                       <a:round/>
@@ -4054,7 +4618,7 @@
                     </a:lnT>
                     <a:lnB w="9525" cap="flat" cmpd="sng" algn="ctr">
                       <a:solidFill>
-                        <a:srgbClr val="D5DDE8"/>
+                        <a:srgbClr val="E4DFDC"/>
                       </a:solidFill>
                       <a:prstDash val="solid"/>
                       <a:round/>
@@ -4095,7 +4659,7 @@
                   <a:tcPr marL="109728" marR="109728" marT="109728" marB="109728" anchor="ctr">
                     <a:lnL w="9525" cap="flat" cmpd="sng" algn="ctr">
                       <a:solidFill>
-                        <a:srgbClr val="D5DDE8"/>
+                        <a:srgbClr val="E4DFDC"/>
                       </a:solidFill>
                       <a:prstDash val="solid"/>
                       <a:round/>
@@ -4104,7 +4668,7 @@
                     </a:lnL>
                     <a:lnR w="9525" cap="flat" cmpd="sng" algn="ctr">
                       <a:solidFill>
-                        <a:srgbClr val="D5DDE8"/>
+                        <a:srgbClr val="E4DFDC"/>
                       </a:solidFill>
                       <a:prstDash val="solid"/>
                       <a:round/>
@@ -4113,7 +4677,7 @@
                     </a:lnR>
                     <a:lnT w="9525" cap="flat" cmpd="sng" algn="ctr">
                       <a:solidFill>
-                        <a:srgbClr val="D5DDE8"/>
+                        <a:srgbClr val="E4DFDC"/>
                       </a:solidFill>
                       <a:prstDash val="solid"/>
                       <a:round/>
@@ -4122,7 +4686,7 @@
                     </a:lnT>
                     <a:lnB w="9525" cap="flat" cmpd="sng" algn="ctr">
                       <a:solidFill>
-                        <a:srgbClr val="D5DDE8"/>
+                        <a:srgbClr val="E4DFDC"/>
                       </a:solidFill>
                       <a:prstDash val="solid"/>
                       <a:round/>
@@ -4217,6 +4781,118 @@
           </a:p>
         </p:txBody>
       </p:sp>
+      <p:sp>
+        <p:nvSpPr>
+          <p:cNvPr id="8" name="Rectangle 7"/>
+          <p:cNvSpPr/>
+          <p:nvPr/>
+        </p:nvSpPr>
+        <p:spPr>
+          <a:xfrm>
+            <a:off x="0" y="0"/>
+            <a:ext cx="12192000" cy="82296"/>
+          </a:xfrm>
+          <a:prstGeom prst="rect">
+            <a:avLst/>
+          </a:prstGeom>
+          <a:solidFill>
+            <a:srgbClr val="201F20"/>
+          </a:solidFill>
+          <a:ln>
+            <a:noFill/>
+          </a:ln>
+          <a:effectLst/>
+        </p:spPr>
+        <p:style>
+          <a:lnRef idx="1">
+            <a:schemeClr val="accent1"/>
+          </a:lnRef>
+          <a:fillRef idx="3">
+            <a:schemeClr val="accent1"/>
+          </a:fillRef>
+          <a:effectRef idx="2">
+            <a:schemeClr val="accent1"/>
+          </a:effectRef>
+          <a:fontRef idx="minor">
+            <a:schemeClr val="lt1"/>
+          </a:fontRef>
+        </p:style>
+        <p:txBody>
+          <a:bodyPr rtlCol="0" anchor="ctr"/>
+          <a:lstStyle/>
+          <a:p>
+            <a:pPr algn="ctr"/>
+          </a:p>
+        </p:txBody>
+      </p:sp>
+      <p:sp>
+        <p:nvSpPr>
+          <p:cNvPr id="9" name="Rectangle 8"/>
+          <p:cNvSpPr/>
+          <p:nvPr/>
+        </p:nvSpPr>
+        <p:spPr>
+          <a:xfrm>
+            <a:off x="0" y="82296"/>
+            <a:ext cx="1463040" cy="45720"/>
+          </a:xfrm>
+          <a:prstGeom prst="rect">
+            <a:avLst/>
+          </a:prstGeom>
+          <a:solidFill>
+            <a:srgbClr val="F0561A"/>
+          </a:solidFill>
+          <a:ln>
+            <a:noFill/>
+          </a:ln>
+          <a:effectLst/>
+        </p:spPr>
+        <p:style>
+          <a:lnRef idx="1">
+            <a:schemeClr val="accent1"/>
+          </a:lnRef>
+          <a:fillRef idx="3">
+            <a:schemeClr val="accent1"/>
+          </a:fillRef>
+          <a:effectRef idx="2">
+            <a:schemeClr val="accent1"/>
+          </a:effectRef>
+          <a:fontRef idx="minor">
+            <a:schemeClr val="lt1"/>
+          </a:fontRef>
+        </p:style>
+        <p:txBody>
+          <a:bodyPr rtlCol="0" anchor="ctr"/>
+          <a:lstStyle/>
+          <a:p>
+            <a:pPr algn="ctr"/>
+          </a:p>
+        </p:txBody>
+      </p:sp>
+      <p:pic>
+        <p:nvPicPr>
+          <p:cNvPr id="10" name="Picture 9" descr="indulgetix_logo.png"/>
+          <p:cNvPicPr>
+            <a:picLocks noChangeAspect="1"/>
+          </p:cNvPicPr>
+          <p:nvPr/>
+        </p:nvPicPr>
+        <p:blipFill>
+          <a:blip r:embed="rId3"/>
+          <a:stretch>
+            <a:fillRect/>
+          </a:stretch>
+        </p:blipFill>
+        <p:spPr>
+          <a:xfrm>
+            <a:off x="10563218" y="6336792"/>
+            <a:ext cx="605804" cy="384047"/>
+          </a:xfrm>
+          <a:prstGeom prst="rect">
+            <a:avLst/>
+          </a:prstGeom>
+        </p:spPr>
+      </p:pic>
     </p:spTree>
   </p:cSld>
   <p:clrMapOvr>
@@ -4276,7 +4952,7 @@
             <a:r>
               <a:rPr lang="en-US" sz="2600" b="1" dirty="0">
                 <a:solidFill>
-                  <a:srgbClr val="15253D"/>
+                  <a:srgbClr val="201F20"/>
                 </a:solidFill>
                 <a:latin typeface="Arial" pitchFamily="34" charset="0"/>
                 <a:ea typeface="Arial" pitchFamily="34" charset="-122"/>
@@ -4384,7 +5060,7 @@
                   <a:tcPr marL="109728" marR="109728" marT="109728" marB="109728" anchor="ctr">
                     <a:lnL w="9525" cap="flat" cmpd="sng" algn="ctr">
                       <a:solidFill>
-                        <a:srgbClr val="D5DDE8"/>
+                        <a:srgbClr val="E4DFDC"/>
                       </a:solidFill>
                       <a:prstDash val="solid"/>
                       <a:round/>
@@ -4393,7 +5069,7 @@
                     </a:lnL>
                     <a:lnR w="9525" cap="flat" cmpd="sng" algn="ctr">
                       <a:solidFill>
-                        <a:srgbClr val="D5DDE8"/>
+                        <a:srgbClr val="E4DFDC"/>
                       </a:solidFill>
                       <a:prstDash val="solid"/>
                       <a:round/>
@@ -4402,7 +5078,7 @@
                     </a:lnR>
                     <a:lnT w="9525" cap="flat" cmpd="sng" algn="ctr">
                       <a:solidFill>
-                        <a:srgbClr val="D5DDE8"/>
+                        <a:srgbClr val="E4DFDC"/>
                       </a:solidFill>
                       <a:prstDash val="solid"/>
                       <a:round/>
@@ -4411,7 +5087,7 @@
                     </a:lnT>
                     <a:lnB w="9525" cap="flat" cmpd="sng" algn="ctr">
                       <a:solidFill>
-                        <a:srgbClr val="D5DDE8"/>
+                        <a:srgbClr val="E4DFDC"/>
                       </a:solidFill>
                       <a:prstDash val="solid"/>
                       <a:round/>
@@ -4419,7 +5095,7 @@
                       <a:tailEnd type="none" w="med" len="med"/>
                     </a:lnB>
                     <a:solidFill>
-                      <a:srgbClr val="15253D"/>
+                      <a:srgbClr val="201F20"/>
                     </a:solidFill>
                   </a:tcPr>
                 </a:tc>
@@ -4452,7 +5128,7 @@
                   <a:tcPr marL="109728" marR="109728" marT="109728" marB="109728" anchor="ctr">
                     <a:lnL w="9525" cap="flat" cmpd="sng" algn="ctr">
                       <a:solidFill>
-                        <a:srgbClr val="D5DDE8"/>
+                        <a:srgbClr val="E4DFDC"/>
                       </a:solidFill>
                       <a:prstDash val="solid"/>
                       <a:round/>
@@ -4461,7 +5137,7 @@
                     </a:lnL>
                     <a:lnR w="9525" cap="flat" cmpd="sng" algn="ctr">
                       <a:solidFill>
-                        <a:srgbClr val="D5DDE8"/>
+                        <a:srgbClr val="E4DFDC"/>
                       </a:solidFill>
                       <a:prstDash val="solid"/>
                       <a:round/>
@@ -4470,7 +5146,7 @@
                     </a:lnR>
                     <a:lnT w="9525" cap="flat" cmpd="sng" algn="ctr">
                       <a:solidFill>
-                        <a:srgbClr val="D5DDE8"/>
+                        <a:srgbClr val="E4DFDC"/>
                       </a:solidFill>
                       <a:prstDash val="solid"/>
                       <a:round/>
@@ -4479,7 +5155,7 @@
                     </a:lnT>
                     <a:lnB w="9525" cap="flat" cmpd="sng" algn="ctr">
                       <a:solidFill>
-                        <a:srgbClr val="D5DDE8"/>
+                        <a:srgbClr val="E4DFDC"/>
                       </a:solidFill>
                       <a:prstDash val="solid"/>
                       <a:round/>
@@ -4487,7 +5163,7 @@
                       <a:tailEnd type="none" w="med" len="med"/>
                     </a:lnB>
                     <a:solidFill>
-                      <a:srgbClr val="15253D"/>
+                      <a:srgbClr val="201F20"/>
                     </a:solidFill>
                   </a:tcPr>
                 </a:tc>
@@ -4520,7 +5196,7 @@
                   <a:tcPr marL="109728" marR="109728" marT="109728" marB="109728" anchor="ctr">
                     <a:lnL w="9525" cap="flat" cmpd="sng" algn="ctr">
                       <a:solidFill>
-                        <a:srgbClr val="D5DDE8"/>
+                        <a:srgbClr val="E4DFDC"/>
                       </a:solidFill>
                       <a:prstDash val="solid"/>
                       <a:round/>
@@ -4529,7 +5205,7 @@
                     </a:lnL>
                     <a:lnR w="9525" cap="flat" cmpd="sng" algn="ctr">
                       <a:solidFill>
-                        <a:srgbClr val="D5DDE8"/>
+                        <a:srgbClr val="E4DFDC"/>
                       </a:solidFill>
                       <a:prstDash val="solid"/>
                       <a:round/>
@@ -4538,7 +5214,7 @@
                     </a:lnR>
                     <a:lnT w="9525" cap="flat" cmpd="sng" algn="ctr">
                       <a:solidFill>
-                        <a:srgbClr val="D5DDE8"/>
+                        <a:srgbClr val="E4DFDC"/>
                       </a:solidFill>
                       <a:prstDash val="solid"/>
                       <a:round/>
@@ -4547,7 +5223,7 @@
                     </a:lnT>
                     <a:lnB w="9525" cap="flat" cmpd="sng" algn="ctr">
                       <a:solidFill>
-                        <a:srgbClr val="D5DDE8"/>
+                        <a:srgbClr val="E4DFDC"/>
                       </a:solidFill>
                       <a:prstDash val="solid"/>
                       <a:round/>
@@ -4555,7 +5231,7 @@
                       <a:tailEnd type="none" w="med" len="med"/>
                     </a:lnB>
                     <a:solidFill>
-                      <a:srgbClr val="15253D"/>
+                      <a:srgbClr val="201F20"/>
                     </a:solidFill>
                   </a:tcPr>
                 </a:tc>
@@ -4572,7 +5248,7 @@
                       <a:r>
                         <a:rPr lang="en-US" sz="1500" b="1" dirty="0">
                           <a:solidFill>
-                            <a:srgbClr val="0F766E"/>
+                            <a:srgbClr val="D9480F"/>
                           </a:solidFill>
                           <a:latin typeface="Arial" pitchFamily="34" charset="0"/>
                           <a:ea typeface="Arial" pitchFamily="34" charset="-122"/>
@@ -4590,7 +5266,7 @@
                   <a:tcPr marL="109728" marR="109728" marT="109728" marB="109728" anchor="ctr">
                     <a:lnL w="9525" cap="flat" cmpd="sng" algn="ctr">
                       <a:solidFill>
-                        <a:srgbClr val="D5DDE8"/>
+                        <a:srgbClr val="E4DFDC"/>
                       </a:solidFill>
                       <a:prstDash val="solid"/>
                       <a:round/>
@@ -4599,7 +5275,7 @@
                     </a:lnL>
                     <a:lnR w="9525" cap="flat" cmpd="sng" algn="ctr">
                       <a:solidFill>
-                        <a:srgbClr val="D5DDE8"/>
+                        <a:srgbClr val="E4DFDC"/>
                       </a:solidFill>
                       <a:prstDash val="solid"/>
                       <a:round/>
@@ -4608,7 +5284,7 @@
                     </a:lnR>
                     <a:lnT w="9525" cap="flat" cmpd="sng" algn="ctr">
                       <a:solidFill>
-                        <a:srgbClr val="D5DDE8"/>
+                        <a:srgbClr val="E4DFDC"/>
                       </a:solidFill>
                       <a:prstDash val="solid"/>
                       <a:round/>
@@ -4617,7 +5293,7 @@
                     </a:lnT>
                     <a:lnB w="9525" cap="flat" cmpd="sng" algn="ctr">
                       <a:solidFill>
-                        <a:srgbClr val="D5DDE8"/>
+                        <a:srgbClr val="E4DFDC"/>
                       </a:solidFill>
                       <a:prstDash val="solid"/>
                       <a:round/>
@@ -4625,7 +5301,7 @@
                       <a:tailEnd type="none" w="med" len="med"/>
                     </a:lnB>
                     <a:solidFill>
-                      <a:srgbClr val="F4F7FB"/>
+                      <a:srgbClr val="F7F5F4"/>
                     </a:solidFill>
                   </a:tcPr>
                 </a:tc>
@@ -4658,7 +5334,7 @@
                   <a:tcPr marL="109728" marR="109728" marT="109728" marB="109728" anchor="ctr">
                     <a:lnL w="9525" cap="flat" cmpd="sng" algn="ctr">
                       <a:solidFill>
-                        <a:srgbClr val="D5DDE8"/>
+                        <a:srgbClr val="E4DFDC"/>
                       </a:solidFill>
                       <a:prstDash val="solid"/>
                       <a:round/>
@@ -4667,7 +5343,7 @@
                     </a:lnL>
                     <a:lnR w="9525" cap="flat" cmpd="sng" algn="ctr">
                       <a:solidFill>
-                        <a:srgbClr val="D5DDE8"/>
+                        <a:srgbClr val="E4DFDC"/>
                       </a:solidFill>
                       <a:prstDash val="solid"/>
                       <a:round/>
@@ -4676,7 +5352,7 @@
                     </a:lnR>
                     <a:lnT w="9525" cap="flat" cmpd="sng" algn="ctr">
                       <a:solidFill>
-                        <a:srgbClr val="D5DDE8"/>
+                        <a:srgbClr val="E4DFDC"/>
                       </a:solidFill>
                       <a:prstDash val="solid"/>
                       <a:round/>
@@ -4685,7 +5361,7 @@
                     </a:lnT>
                     <a:lnB w="9525" cap="flat" cmpd="sng" algn="ctr">
                       <a:solidFill>
-                        <a:srgbClr val="D5DDE8"/>
+                        <a:srgbClr val="E4DFDC"/>
                       </a:solidFill>
                       <a:prstDash val="solid"/>
                       <a:round/>
@@ -4693,7 +5369,7 @@
                       <a:tailEnd type="none" w="med" len="med"/>
                     </a:lnB>
                     <a:solidFill>
-                      <a:srgbClr val="F4F7FB"/>
+                      <a:srgbClr val="F7F5F4"/>
                     </a:solidFill>
                   </a:tcPr>
                 </a:tc>
@@ -4726,7 +5402,7 @@
                   <a:tcPr marL="109728" marR="109728" marT="109728" marB="109728" anchor="ctr">
                     <a:lnL w="9525" cap="flat" cmpd="sng" algn="ctr">
                       <a:solidFill>
-                        <a:srgbClr val="D5DDE8"/>
+                        <a:srgbClr val="E4DFDC"/>
                       </a:solidFill>
                       <a:prstDash val="solid"/>
                       <a:round/>
@@ -4735,7 +5411,7 @@
                     </a:lnL>
                     <a:lnR w="9525" cap="flat" cmpd="sng" algn="ctr">
                       <a:solidFill>
-                        <a:srgbClr val="D5DDE8"/>
+                        <a:srgbClr val="E4DFDC"/>
                       </a:solidFill>
                       <a:prstDash val="solid"/>
                       <a:round/>
@@ -4744,7 +5420,7 @@
                     </a:lnR>
                     <a:lnT w="9525" cap="flat" cmpd="sng" algn="ctr">
                       <a:solidFill>
-                        <a:srgbClr val="D5DDE8"/>
+                        <a:srgbClr val="E4DFDC"/>
                       </a:solidFill>
                       <a:prstDash val="solid"/>
                       <a:round/>
@@ -4753,7 +5429,7 @@
                     </a:lnT>
                     <a:lnB w="9525" cap="flat" cmpd="sng" algn="ctr">
                       <a:solidFill>
-                        <a:srgbClr val="D5DDE8"/>
+                        <a:srgbClr val="E4DFDC"/>
                       </a:solidFill>
                       <a:prstDash val="solid"/>
                       <a:round/>
@@ -4761,7 +5437,7 @@
                       <a:tailEnd type="none" w="med" len="med"/>
                     </a:lnB>
                     <a:solidFill>
-                      <a:srgbClr val="F4F7FB"/>
+                      <a:srgbClr val="F7F5F4"/>
                     </a:solidFill>
                   </a:tcPr>
                 </a:tc>
@@ -4778,7 +5454,7 @@
                       <a:r>
                         <a:rPr lang="en-US" sz="1500" b="1" dirty="0">
                           <a:solidFill>
-                            <a:srgbClr val="0F766E"/>
+                            <a:srgbClr val="D9480F"/>
                           </a:solidFill>
                           <a:latin typeface="Arial" pitchFamily="34" charset="0"/>
                           <a:ea typeface="Arial" pitchFamily="34" charset="-122"/>
@@ -4796,7 +5472,7 @@
                   <a:tcPr marL="109728" marR="109728" marT="109728" marB="109728" anchor="ctr">
                     <a:lnL w="9525" cap="flat" cmpd="sng" algn="ctr">
                       <a:solidFill>
-                        <a:srgbClr val="D5DDE8"/>
+                        <a:srgbClr val="E4DFDC"/>
                       </a:solidFill>
                       <a:prstDash val="solid"/>
                       <a:round/>
@@ -4805,7 +5481,7 @@
                     </a:lnL>
                     <a:lnR w="9525" cap="flat" cmpd="sng" algn="ctr">
                       <a:solidFill>
-                        <a:srgbClr val="D5DDE8"/>
+                        <a:srgbClr val="E4DFDC"/>
                       </a:solidFill>
                       <a:prstDash val="solid"/>
                       <a:round/>
@@ -4814,7 +5490,7 @@
                     </a:lnR>
                     <a:lnT w="9525" cap="flat" cmpd="sng" algn="ctr">
                       <a:solidFill>
-                        <a:srgbClr val="D5DDE8"/>
+                        <a:srgbClr val="E4DFDC"/>
                       </a:solidFill>
                       <a:prstDash val="solid"/>
                       <a:round/>
@@ -4823,7 +5499,7 @@
                     </a:lnT>
                     <a:lnB w="9525" cap="flat" cmpd="sng" algn="ctr">
                       <a:solidFill>
-                        <a:srgbClr val="D5DDE8"/>
+                        <a:srgbClr val="E4DFDC"/>
                       </a:solidFill>
                       <a:prstDash val="solid"/>
                       <a:round/>
@@ -4864,7 +5540,7 @@
                   <a:tcPr marL="109728" marR="109728" marT="109728" marB="109728" anchor="ctr">
                     <a:lnL w="9525" cap="flat" cmpd="sng" algn="ctr">
                       <a:solidFill>
-                        <a:srgbClr val="D5DDE8"/>
+                        <a:srgbClr val="E4DFDC"/>
                       </a:solidFill>
                       <a:prstDash val="solid"/>
                       <a:round/>
@@ -4873,7 +5549,7 @@
                     </a:lnL>
                     <a:lnR w="9525" cap="flat" cmpd="sng" algn="ctr">
                       <a:solidFill>
-                        <a:srgbClr val="D5DDE8"/>
+                        <a:srgbClr val="E4DFDC"/>
                       </a:solidFill>
                       <a:prstDash val="solid"/>
                       <a:round/>
@@ -4882,7 +5558,7 @@
                     </a:lnR>
                     <a:lnT w="9525" cap="flat" cmpd="sng" algn="ctr">
                       <a:solidFill>
-                        <a:srgbClr val="D5DDE8"/>
+                        <a:srgbClr val="E4DFDC"/>
                       </a:solidFill>
                       <a:prstDash val="solid"/>
                       <a:round/>
@@ -4891,7 +5567,7 @@
                     </a:lnT>
                     <a:lnB w="9525" cap="flat" cmpd="sng" algn="ctr">
                       <a:solidFill>
-                        <a:srgbClr val="D5DDE8"/>
+                        <a:srgbClr val="E4DFDC"/>
                       </a:solidFill>
                       <a:prstDash val="solid"/>
                       <a:round/>
@@ -4932,7 +5608,7 @@
                   <a:tcPr marL="109728" marR="109728" marT="109728" marB="109728" anchor="ctr">
                     <a:lnL w="9525" cap="flat" cmpd="sng" algn="ctr">
                       <a:solidFill>
-                        <a:srgbClr val="D5DDE8"/>
+                        <a:srgbClr val="E4DFDC"/>
                       </a:solidFill>
                       <a:prstDash val="solid"/>
                       <a:round/>
@@ -4941,7 +5617,7 @@
                     </a:lnL>
                     <a:lnR w="9525" cap="flat" cmpd="sng" algn="ctr">
                       <a:solidFill>
-                        <a:srgbClr val="D5DDE8"/>
+                        <a:srgbClr val="E4DFDC"/>
                       </a:solidFill>
                       <a:prstDash val="solid"/>
                       <a:round/>
@@ -4950,7 +5626,7 @@
                     </a:lnR>
                     <a:lnT w="9525" cap="flat" cmpd="sng" algn="ctr">
                       <a:solidFill>
-                        <a:srgbClr val="D5DDE8"/>
+                        <a:srgbClr val="E4DFDC"/>
                       </a:solidFill>
                       <a:prstDash val="solid"/>
                       <a:round/>
@@ -4959,7 +5635,7 @@
                     </a:lnT>
                     <a:lnB w="9525" cap="flat" cmpd="sng" algn="ctr">
                       <a:solidFill>
-                        <a:srgbClr val="D5DDE8"/>
+                        <a:srgbClr val="E4DFDC"/>
                       </a:solidFill>
                       <a:prstDash val="solid"/>
                       <a:round/>
@@ -4984,7 +5660,7 @@
                       <a:r>
                         <a:rPr lang="en-US" sz="1500" b="1" dirty="0">
                           <a:solidFill>
-                            <a:srgbClr val="0F766E"/>
+                            <a:srgbClr val="D9480F"/>
                           </a:solidFill>
                           <a:latin typeface="Arial" pitchFamily="34" charset="0"/>
                           <a:ea typeface="Arial" pitchFamily="34" charset="-122"/>
@@ -5002,7 +5678,7 @@
                   <a:tcPr marL="109728" marR="109728" marT="109728" marB="109728" anchor="ctr">
                     <a:lnL w="9525" cap="flat" cmpd="sng" algn="ctr">
                       <a:solidFill>
-                        <a:srgbClr val="D5DDE8"/>
+                        <a:srgbClr val="E4DFDC"/>
                       </a:solidFill>
                       <a:prstDash val="solid"/>
                       <a:round/>
@@ -5011,7 +5687,7 @@
                     </a:lnL>
                     <a:lnR w="9525" cap="flat" cmpd="sng" algn="ctr">
                       <a:solidFill>
-                        <a:srgbClr val="D5DDE8"/>
+                        <a:srgbClr val="E4DFDC"/>
                       </a:solidFill>
                       <a:prstDash val="solid"/>
                       <a:round/>
@@ -5020,7 +5696,7 @@
                     </a:lnR>
                     <a:lnT w="9525" cap="flat" cmpd="sng" algn="ctr">
                       <a:solidFill>
-                        <a:srgbClr val="D5DDE8"/>
+                        <a:srgbClr val="E4DFDC"/>
                       </a:solidFill>
                       <a:prstDash val="solid"/>
                       <a:round/>
@@ -5029,7 +5705,7 @@
                     </a:lnT>
                     <a:lnB w="9525" cap="flat" cmpd="sng" algn="ctr">
                       <a:solidFill>
-                        <a:srgbClr val="D5DDE8"/>
+                        <a:srgbClr val="E4DFDC"/>
                       </a:solidFill>
                       <a:prstDash val="solid"/>
                       <a:round/>
@@ -5037,7 +5713,7 @@
                       <a:tailEnd type="none" w="med" len="med"/>
                     </a:lnB>
                     <a:solidFill>
-                      <a:srgbClr val="F4F7FB"/>
+                      <a:srgbClr val="F7F5F4"/>
                     </a:solidFill>
                   </a:tcPr>
                 </a:tc>
@@ -5070,7 +5746,7 @@
                   <a:tcPr marL="109728" marR="109728" marT="109728" marB="109728" anchor="ctr">
                     <a:lnL w="9525" cap="flat" cmpd="sng" algn="ctr">
                       <a:solidFill>
-                        <a:srgbClr val="D5DDE8"/>
+                        <a:srgbClr val="E4DFDC"/>
                       </a:solidFill>
                       <a:prstDash val="solid"/>
                       <a:round/>
@@ -5079,7 +5755,7 @@
                     </a:lnL>
                     <a:lnR w="9525" cap="flat" cmpd="sng" algn="ctr">
                       <a:solidFill>
-                        <a:srgbClr val="D5DDE8"/>
+                        <a:srgbClr val="E4DFDC"/>
                       </a:solidFill>
                       <a:prstDash val="solid"/>
                       <a:round/>
@@ -5088,7 +5764,7 @@
                     </a:lnR>
                     <a:lnT w="9525" cap="flat" cmpd="sng" algn="ctr">
                       <a:solidFill>
-                        <a:srgbClr val="D5DDE8"/>
+                        <a:srgbClr val="E4DFDC"/>
                       </a:solidFill>
                       <a:prstDash val="solid"/>
                       <a:round/>
@@ -5097,7 +5773,7 @@
                     </a:lnT>
                     <a:lnB w="9525" cap="flat" cmpd="sng" algn="ctr">
                       <a:solidFill>
-                        <a:srgbClr val="D5DDE8"/>
+                        <a:srgbClr val="E4DFDC"/>
                       </a:solidFill>
                       <a:prstDash val="solid"/>
                       <a:round/>
@@ -5105,7 +5781,7 @@
                       <a:tailEnd type="none" w="med" len="med"/>
                     </a:lnB>
                     <a:solidFill>
-                      <a:srgbClr val="F4F7FB"/>
+                      <a:srgbClr val="F7F5F4"/>
                     </a:solidFill>
                   </a:tcPr>
                 </a:tc>
@@ -5138,7 +5814,7 @@
                   <a:tcPr marL="109728" marR="109728" marT="109728" marB="109728" anchor="ctr">
                     <a:lnL w="9525" cap="flat" cmpd="sng" algn="ctr">
                       <a:solidFill>
-                        <a:srgbClr val="D5DDE8"/>
+                        <a:srgbClr val="E4DFDC"/>
                       </a:solidFill>
                       <a:prstDash val="solid"/>
                       <a:round/>
@@ -5147,7 +5823,7 @@
                     </a:lnL>
                     <a:lnR w="9525" cap="flat" cmpd="sng" algn="ctr">
                       <a:solidFill>
-                        <a:srgbClr val="D5DDE8"/>
+                        <a:srgbClr val="E4DFDC"/>
                       </a:solidFill>
                       <a:prstDash val="solid"/>
                       <a:round/>
@@ -5156,7 +5832,7 @@
                     </a:lnR>
                     <a:lnT w="9525" cap="flat" cmpd="sng" algn="ctr">
                       <a:solidFill>
-                        <a:srgbClr val="D5DDE8"/>
+                        <a:srgbClr val="E4DFDC"/>
                       </a:solidFill>
                       <a:prstDash val="solid"/>
                       <a:round/>
@@ -5165,7 +5841,7 @@
                     </a:lnT>
                     <a:lnB w="9525" cap="flat" cmpd="sng" algn="ctr">
                       <a:solidFill>
-                        <a:srgbClr val="D5DDE8"/>
+                        <a:srgbClr val="E4DFDC"/>
                       </a:solidFill>
                       <a:prstDash val="solid"/>
                       <a:round/>
@@ -5173,7 +5849,7 @@
                       <a:tailEnd type="none" w="med" len="med"/>
                     </a:lnB>
                     <a:solidFill>
-                      <a:srgbClr val="F4F7FB"/>
+                      <a:srgbClr val="F7F5F4"/>
                     </a:solidFill>
                   </a:tcPr>
                 </a:tc>
@@ -5260,6 +5936,118 @@
           </a:p>
         </p:txBody>
       </p:sp>
+      <p:sp>
+        <p:nvSpPr>
+          <p:cNvPr id="9" name="Rectangle 8"/>
+          <p:cNvSpPr/>
+          <p:nvPr/>
+        </p:nvSpPr>
+        <p:spPr>
+          <a:xfrm>
+            <a:off x="0" y="0"/>
+            <a:ext cx="12192000" cy="82296"/>
+          </a:xfrm>
+          <a:prstGeom prst="rect">
+            <a:avLst/>
+          </a:prstGeom>
+          <a:solidFill>
+            <a:srgbClr val="201F20"/>
+          </a:solidFill>
+          <a:ln>
+            <a:noFill/>
+          </a:ln>
+          <a:effectLst/>
+        </p:spPr>
+        <p:style>
+          <a:lnRef idx="1">
+            <a:schemeClr val="accent1"/>
+          </a:lnRef>
+          <a:fillRef idx="3">
+            <a:schemeClr val="accent1"/>
+          </a:fillRef>
+          <a:effectRef idx="2">
+            <a:schemeClr val="accent1"/>
+          </a:effectRef>
+          <a:fontRef idx="minor">
+            <a:schemeClr val="lt1"/>
+          </a:fontRef>
+        </p:style>
+        <p:txBody>
+          <a:bodyPr rtlCol="0" anchor="ctr"/>
+          <a:lstStyle/>
+          <a:p>
+            <a:pPr algn="ctr"/>
+          </a:p>
+        </p:txBody>
+      </p:sp>
+      <p:sp>
+        <p:nvSpPr>
+          <p:cNvPr id="10" name="Rectangle 9"/>
+          <p:cNvSpPr/>
+          <p:nvPr/>
+        </p:nvSpPr>
+        <p:spPr>
+          <a:xfrm>
+            <a:off x="0" y="82296"/>
+            <a:ext cx="1463040" cy="45720"/>
+          </a:xfrm>
+          <a:prstGeom prst="rect">
+            <a:avLst/>
+          </a:prstGeom>
+          <a:solidFill>
+            <a:srgbClr val="F0561A"/>
+          </a:solidFill>
+          <a:ln>
+            <a:noFill/>
+          </a:ln>
+          <a:effectLst/>
+        </p:spPr>
+        <p:style>
+          <a:lnRef idx="1">
+            <a:schemeClr val="accent1"/>
+          </a:lnRef>
+          <a:fillRef idx="3">
+            <a:schemeClr val="accent1"/>
+          </a:fillRef>
+          <a:effectRef idx="2">
+            <a:schemeClr val="accent1"/>
+          </a:effectRef>
+          <a:fontRef idx="minor">
+            <a:schemeClr val="lt1"/>
+          </a:fontRef>
+        </p:style>
+        <p:txBody>
+          <a:bodyPr rtlCol="0" anchor="ctr"/>
+          <a:lstStyle/>
+          <a:p>
+            <a:pPr algn="ctr"/>
+          </a:p>
+        </p:txBody>
+      </p:sp>
+      <p:pic>
+        <p:nvPicPr>
+          <p:cNvPr id="11" name="Picture 10" descr="indulgetix_logo.png"/>
+          <p:cNvPicPr>
+            <a:picLocks noChangeAspect="1"/>
+          </p:cNvPicPr>
+          <p:nvPr/>
+        </p:nvPicPr>
+        <p:blipFill>
+          <a:blip r:embed="rId3"/>
+          <a:stretch>
+            <a:fillRect/>
+          </a:stretch>
+        </p:blipFill>
+        <p:spPr>
+          <a:xfrm>
+            <a:off x="10563218" y="6336792"/>
+            <a:ext cx="605804" cy="384047"/>
+          </a:xfrm>
+          <a:prstGeom prst="rect">
+            <a:avLst/>
+          </a:prstGeom>
+        </p:spPr>
+      </p:pic>
     </p:spTree>
   </p:cSld>
   <p:clrMapOvr>
@@ -5319,7 +6107,7 @@
             <a:r>
               <a:rPr lang="en-US" sz="2600" b="1" dirty="0">
                 <a:solidFill>
-                  <a:srgbClr val="15253D"/>
+                  <a:srgbClr val="201F20"/>
                 </a:solidFill>
                 <a:latin typeface="Arial" pitchFamily="34" charset="0"/>
                 <a:ea typeface="Arial" pitchFamily="34" charset="-122"/>
@@ -5358,7 +6146,7 @@
             <a:r>
               <a:rPr lang="en-US" sz="1500" b="1" dirty="0">
                 <a:solidFill>
-                  <a:srgbClr val="0F766E"/>
+                  <a:srgbClr val="D9480F"/>
                 </a:solidFill>
                 <a:latin typeface="Arial" pitchFamily="34" charset="0"/>
                 <a:ea typeface="Arial" pitchFamily="34" charset="-122"/>
@@ -5503,7 +6291,7 @@
             <a:r>
               <a:rPr lang="en-US" sz="1500" b="1" dirty="0">
                 <a:solidFill>
-                  <a:srgbClr val="EA580C"/>
+                  <a:srgbClr val="F0561A"/>
                 </a:solidFill>
                 <a:latin typeface="Arial" pitchFamily="34" charset="0"/>
                 <a:ea typeface="Arial" pitchFamily="34" charset="-122"/>
@@ -5530,11 +6318,11 @@
             <a:avLst/>
           </a:prstGeom>
           <a:solidFill>
-            <a:srgbClr val="F4F7FB"/>
+            <a:srgbClr val="F7F5F4"/>
           </a:solidFill>
           <a:ln w="12700">
             <a:solidFill>
-              <a:srgbClr val="F4F7FB"/>
+              <a:srgbClr val="F7F5F4"/>
             </a:solidFill>
             <a:prstDash val="solid"/>
           </a:ln>
@@ -5674,11 +6462,11 @@
             <a:avLst/>
           </a:prstGeom>
           <a:solidFill>
-            <a:srgbClr val="F4F7FB"/>
+            <a:srgbClr val="F7F5F4"/>
           </a:solidFill>
           <a:ln w="12700">
             <a:solidFill>
-              <a:srgbClr val="F4F7FB"/>
+              <a:srgbClr val="F7F5F4"/>
             </a:solidFill>
             <a:prstDash val="solid"/>
           </a:ln>
@@ -5818,11 +6606,11 @@
             <a:avLst/>
           </a:prstGeom>
           <a:solidFill>
-            <a:srgbClr val="F4F7FB"/>
+            <a:srgbClr val="F7F5F4"/>
           </a:solidFill>
           <a:ln w="12700">
             <a:solidFill>
-              <a:srgbClr val="F4F7FB"/>
+              <a:srgbClr val="F7F5F4"/>
             </a:solidFill>
             <a:prstDash val="solid"/>
           </a:ln>
@@ -5962,11 +6750,11 @@
             <a:avLst/>
           </a:prstGeom>
           <a:solidFill>
-            <a:srgbClr val="F4F7FB"/>
+            <a:srgbClr val="F7F5F4"/>
           </a:solidFill>
           <a:ln w="12700">
             <a:solidFill>
-              <a:srgbClr val="F4F7FB"/>
+              <a:srgbClr val="F7F5F4"/>
             </a:solidFill>
             <a:prstDash val="solid"/>
           </a:ln>
@@ -6169,6 +6957,118 @@
           </a:p>
         </p:txBody>
       </p:sp>
+      <p:sp>
+        <p:nvSpPr>
+          <p:cNvPr id="24" name="Rectangle 23"/>
+          <p:cNvSpPr/>
+          <p:nvPr/>
+        </p:nvSpPr>
+        <p:spPr>
+          <a:xfrm>
+            <a:off x="0" y="0"/>
+            <a:ext cx="12192000" cy="82296"/>
+          </a:xfrm>
+          <a:prstGeom prst="rect">
+            <a:avLst/>
+          </a:prstGeom>
+          <a:solidFill>
+            <a:srgbClr val="201F20"/>
+          </a:solidFill>
+          <a:ln>
+            <a:noFill/>
+          </a:ln>
+          <a:effectLst/>
+        </p:spPr>
+        <p:style>
+          <a:lnRef idx="1">
+            <a:schemeClr val="accent1"/>
+          </a:lnRef>
+          <a:fillRef idx="3">
+            <a:schemeClr val="accent1"/>
+          </a:fillRef>
+          <a:effectRef idx="2">
+            <a:schemeClr val="accent1"/>
+          </a:effectRef>
+          <a:fontRef idx="minor">
+            <a:schemeClr val="lt1"/>
+          </a:fontRef>
+        </p:style>
+        <p:txBody>
+          <a:bodyPr rtlCol="0" anchor="ctr"/>
+          <a:lstStyle/>
+          <a:p>
+            <a:pPr algn="ctr"/>
+          </a:p>
+        </p:txBody>
+      </p:sp>
+      <p:sp>
+        <p:nvSpPr>
+          <p:cNvPr id="25" name="Rectangle 24"/>
+          <p:cNvSpPr/>
+          <p:nvPr/>
+        </p:nvSpPr>
+        <p:spPr>
+          <a:xfrm>
+            <a:off x="0" y="82296"/>
+            <a:ext cx="1463040" cy="45720"/>
+          </a:xfrm>
+          <a:prstGeom prst="rect">
+            <a:avLst/>
+          </a:prstGeom>
+          <a:solidFill>
+            <a:srgbClr val="F0561A"/>
+          </a:solidFill>
+          <a:ln>
+            <a:noFill/>
+          </a:ln>
+          <a:effectLst/>
+        </p:spPr>
+        <p:style>
+          <a:lnRef idx="1">
+            <a:schemeClr val="accent1"/>
+          </a:lnRef>
+          <a:fillRef idx="3">
+            <a:schemeClr val="accent1"/>
+          </a:fillRef>
+          <a:effectRef idx="2">
+            <a:schemeClr val="accent1"/>
+          </a:effectRef>
+          <a:fontRef idx="minor">
+            <a:schemeClr val="lt1"/>
+          </a:fontRef>
+        </p:style>
+        <p:txBody>
+          <a:bodyPr rtlCol="0" anchor="ctr"/>
+          <a:lstStyle/>
+          <a:p>
+            <a:pPr algn="ctr"/>
+          </a:p>
+        </p:txBody>
+      </p:sp>
+      <p:pic>
+        <p:nvPicPr>
+          <p:cNvPr id="26" name="Picture 25" descr="indulgetix_logo.png"/>
+          <p:cNvPicPr>
+            <a:picLocks noChangeAspect="1"/>
+          </p:cNvPicPr>
+          <p:nvPr/>
+        </p:nvPicPr>
+        <p:blipFill>
+          <a:blip r:embed="rId3"/>
+          <a:stretch>
+            <a:fillRect/>
+          </a:stretch>
+        </p:blipFill>
+        <p:spPr>
+          <a:xfrm>
+            <a:off x="10563218" y="6336792"/>
+            <a:ext cx="605804" cy="384047"/>
+          </a:xfrm>
+          <a:prstGeom prst="rect">
+            <a:avLst/>
+          </a:prstGeom>
+        </p:spPr>
+      </p:pic>
     </p:spTree>
   </p:cSld>
   <p:clrMapOvr>

</xml_diff>